<commit_message>
docs: add VANET cryptography recommendations
Co-authored-by: zhang10225 <96326423+zhang10225@users.noreply.github.com>
</commit_message>
<xml_diff>
--- a/docs/vanet-eati-research.pptx
+++ b/docs/vanet-eati-research.pptx
@@ -17,6 +17,8 @@
     <p:sldId id="265" r:id="rId16"/>
     <p:sldId id="266" r:id="rId17"/>
     <p:sldId id="267" r:id="rId18"/>
+    <p:sldId id="268" r:id="rId19"/>
+    <p:sldId id="269" r:id="rId20"/>
   </p:sldIdLst>
   <p:sldSz cx="12191695" cy="6858000" type="screen4x3"/>
   <p:notesSz cx="6858000" cy="9144000"/>
@@ -3245,7 +3247,7 @@
         <p:spPr>
           <a:xfrm>
             <a:off x="548640" y="914400"/>
-            <a:ext cx="10972800" cy="1005840"/>
+            <a:ext cx="10972800" cy="914400"/>
           </a:xfrm>
           <a:prstGeom prst="rect">
             <a:avLst/>
@@ -3278,8 +3280,8 @@
         </p:nvSpPr>
         <p:spPr>
           <a:xfrm>
-            <a:off x="749808" y="2057400"/>
-            <a:ext cx="10789920" cy="640080"/>
+            <a:off x="749808" y="2011680"/>
+            <a:ext cx="10789920" cy="777240"/>
           </a:xfrm>
           <a:prstGeom prst="rect">
             <a:avLst/>
@@ -3293,20 +3295,100 @@
           <a:lstStyle/>
           <a:p>
             <a:r>
-              <a:rPr sz="2200">
+              <a:rPr sz="2000">
                 <a:solidFill>
                   <a:srgbClr val="225DA8"/>
                 </a:solidFill>
                 <a:latin typeface="Microsoft YaHei"/>
               </a:rPr>
-              <a:t>面向弱硬件场景的实时撤销、低 OBU 开销与事后追责</a:t>
-            </a:r>
-          </a:p>
-        </p:txBody>
-      </p:sp>
-      <p:sp>
-        <p:nvSpPr>
-          <p:cNvPr id="7" name="TextBox 6"/>
+              <a:t>补充：推荐密码学算法栈（面向弱硬件、实时撤销与条件追责）</a:t>
+            </a:r>
+          </a:p>
+        </p:txBody>
+      </p:sp>
+      <p:sp>
+        <p:nvSpPr>
+          <p:cNvPr id="7" name="Rounded Rectangle 6"/>
+          <p:cNvSpPr/>
+          <p:nvPr/>
+        </p:nvSpPr>
+        <p:spPr>
+          <a:xfrm>
+            <a:off x="713232" y="4343400"/>
+            <a:ext cx="10789920" cy="1234440"/>
+          </a:xfrm>
+          <a:prstGeom prst="roundRect">
+            <a:avLst/>
+          </a:prstGeom>
+          <a:solidFill>
+            <a:srgbClr val="F5F8FC"/>
+          </a:solidFill>
+          <a:ln>
+            <a:solidFill>
+              <a:srgbClr val="D6DEE8"/>
+            </a:solidFill>
+          </a:ln>
+        </p:spPr>
+        <p:style>
+          <a:lnRef idx="1">
+            <a:schemeClr val="accent1"/>
+          </a:lnRef>
+          <a:fillRef idx="3">
+            <a:schemeClr val="accent1"/>
+          </a:fillRef>
+          <a:effectRef idx="2">
+            <a:schemeClr val="accent1"/>
+          </a:effectRef>
+          <a:fontRef idx="minor">
+            <a:schemeClr val="lt1"/>
+          </a:fontRef>
+        </p:style>
+        <p:txBody>
+          <a:bodyPr rtlCol="0" anchor="ctr"/>
+          <a:lstStyle/>
+          <a:p>
+            <a:pPr algn="ctr"/>
+          </a:p>
+        </p:txBody>
+      </p:sp>
+      <p:sp>
+        <p:nvSpPr>
+          <p:cNvPr id="8" name="TextBox 7"/>
+          <p:cNvSpPr txBox="1"/>
+          <p:nvPr/>
+        </p:nvSpPr>
+        <p:spPr>
+          <a:xfrm>
+            <a:off x="960120" y="4572000"/>
+            <a:ext cx="10149840" cy="731520"/>
+          </a:xfrm>
+          <a:prstGeom prst="rect">
+            <a:avLst/>
+          </a:prstGeom>
+          <a:noFill/>
+        </p:spPr>
+        <p:txBody>
+          <a:bodyPr wrap="none">
+            <a:spAutoFit/>
+          </a:bodyPr>
+          <a:lstStyle/>
+          <a:p>
+            <a:pPr algn="ctr"/>
+            <a:r>
+              <a:rPr sz="2200" b="1">
+                <a:solidFill>
+                  <a:srgbClr val="1D7A57"/>
+                </a:solidFill>
+                <a:latin typeface="Microsoft YaHei"/>
+              </a:rPr>
+              <a:t>推荐算法栈：ECDSA/ECDH P-256 + SHA-256 + AES-GCM + Merkle 透明日志 + 门限解匿</a:t>
+            </a:r>
+          </a:p>
+        </p:txBody>
+      </p:sp>
+      <p:sp>
+        <p:nvSpPr>
+          <p:cNvPr id="9" name="TextBox 8"/>
           <p:cNvSpPr txBox="1"/>
           <p:nvPr/>
         </p:nvSpPr>
@@ -3360,87 +3442,7 @@
                 </a:solidFill>
                 <a:latin typeface="Microsoft YaHei"/>
               </a:rPr>
-              <a:t>交付内容：研究进展、可行性判断、架构映射、分阶段实现路线。</a:t>
-            </a:r>
-          </a:p>
-        </p:txBody>
-      </p:sp>
-      <p:sp>
-        <p:nvSpPr>
-          <p:cNvPr id="8" name="Rounded Rectangle 7"/>
-          <p:cNvSpPr/>
-          <p:nvPr/>
-        </p:nvSpPr>
-        <p:spPr>
-          <a:xfrm>
-            <a:off x="713232" y="4343400"/>
-            <a:ext cx="10789920" cy="1234440"/>
-          </a:xfrm>
-          <a:prstGeom prst="roundRect">
-            <a:avLst/>
-          </a:prstGeom>
-          <a:solidFill>
-            <a:srgbClr val="F5F8FC"/>
-          </a:solidFill>
-          <a:ln>
-            <a:solidFill>
-              <a:srgbClr val="D6DEE8"/>
-            </a:solidFill>
-          </a:ln>
-        </p:spPr>
-        <p:style>
-          <a:lnRef idx="1">
-            <a:schemeClr val="accent1"/>
-          </a:lnRef>
-          <a:fillRef idx="3">
-            <a:schemeClr val="accent1"/>
-          </a:fillRef>
-          <a:effectRef idx="2">
-            <a:schemeClr val="accent1"/>
-          </a:effectRef>
-          <a:fontRef idx="minor">
-            <a:schemeClr val="lt1"/>
-          </a:fontRef>
-        </p:style>
-        <p:txBody>
-          <a:bodyPr rtlCol="0" anchor="ctr"/>
-          <a:lstStyle/>
-          <a:p>
-            <a:pPr algn="ctr"/>
-          </a:p>
-        </p:txBody>
-      </p:sp>
-      <p:sp>
-        <p:nvSpPr>
-          <p:cNvPr id="9" name="TextBox 8"/>
-          <p:cNvSpPr txBox="1"/>
-          <p:nvPr/>
-        </p:nvSpPr>
-        <p:spPr>
-          <a:xfrm>
-            <a:off x="960120" y="4590288"/>
-            <a:ext cx="10149840" cy="731520"/>
-          </a:xfrm>
-          <a:prstGeom prst="rect">
-            <a:avLst/>
-          </a:prstGeom>
-          <a:noFill/>
-        </p:spPr>
-        <p:txBody>
-          <a:bodyPr wrap="none">
-            <a:spAutoFit/>
-          </a:bodyPr>
-          <a:lstStyle/>
-          <a:p>
-            <a:pPr algn="ctr"/>
-            <a:r>
-              <a:rPr sz="2200" b="1">
-                <a:solidFill>
-                  <a:srgbClr val="1D7A57"/>
-                </a:solidFill>
-                <a:latin typeface="Microsoft YaHei"/>
-              </a:rPr>
-              <a:t>建议路线：以 VPKI/SCMS 为主线，叠加边缘化撤销分发、条件解匿和轻量透明日志</a:t>
+              <a:t>新增重点：明确推荐的密码学算法，而不是只给架构原则。</a:t>
             </a:r>
           </a:p>
         </p:txBody>
@@ -3679,7 +3681,7 @@
         <p:spPr>
           <a:xfrm>
             <a:off x="548640" y="749808"/>
-            <a:ext cx="10972800" cy="731520"/>
+            <a:ext cx="10972800" cy="914400"/>
           </a:xfrm>
           <a:prstGeom prst="rect">
             <a:avLst/>
@@ -3699,7 +3701,7 @@
                 </a:solidFill>
                 <a:latin typeface="Microsoft YaHei"/>
               </a:rPr>
-              <a:t>9. 分阶段落地路线图（建议先从封闭/半封闭场景起步）</a:t>
+              <a:t>9. 为什么这套算法最合适</a:t>
             </a:r>
           </a:p>
         </p:txBody>
@@ -3741,7 +3743,7 @@
                 </a:solidFill>
                 <a:latin typeface="Microsoft YaHei"/>
               </a:rPr>
-              <a:t>Phase 0（PoC）：基于 IEEE 1609.2 或 ETSI 102 941/103 097 跑通证书签发、增量撤销、补查、解匿闭环。</a:t>
+              <a:t>ECC 比 RSA 更适合高频广播和密集验签场景：证书/签名更短，车端负担更低。</a:t>
             </a:r>
           </a:p>
           <a:p>
@@ -3760,7 +3762,7 @@
                 </a:solidFill>
                 <a:latin typeface="Microsoft YaHei"/>
               </a:rPr>
-              <a:t>Phase 1（边缘化）：CRL 切成区域 + 时间 + 批次三维差分，OBU 只保留当前窗口摘要。</a:t>
+              <a:t>P-256 / SHA-256 是当前最现实的标准化和工程兼容基线，便于对接现有 VPKI / SCMS / 车规硬件。</a:t>
             </a:r>
           </a:p>
           <a:p>
@@ -3779,7 +3781,7 @@
                 </a:solidFill>
                 <a:latin typeface="Microsoft YaHei"/>
               </a:rPr>
-              <a:t>Phase 2（追责闭环）：关键事件进入本地签名审计日志，透明日志只记录摘要；调查时再生成证据包。</a:t>
+              <a:t>AES-128-GCM 足够满足实时管理面保密需求；后台长期归档可再上 AES-256-GCM。</a:t>
             </a:r>
           </a:p>
           <a:p>
@@ -3798,7 +3800,7 @@
                 </a:solidFill>
                 <a:latin typeface="Microsoft YaHei"/>
               </a:rPr>
-              <a:t>Phase 3（智能化）：AI/规则引擎只负责发现高风险行为，不直接下撤销决定。</a:t>
+              <a:t>Ed25519、BLS、PQC 都有吸引力，但在第一阶段会拉高兼容性、实现复杂度或硬件门槛。</a:t>
             </a:r>
           </a:p>
           <a:p>
@@ -3817,7 +3819,7 @@
                 </a:solidFill>
                 <a:latin typeface="Microsoft YaHei"/>
               </a:rPr>
-              <a:t>首发场景建议：营运车队、物流园区、矿区、港口、两客一危等 RSU/MEC 可控场景。</a:t>
+              <a:t>第一版先把“可部署、可互通、可审计”跑通，比追求最前沿密码原语更重要。</a:t>
             </a:r>
           </a:p>
         </p:txBody>
@@ -3852,7 +3854,7 @@
                 </a:solidFill>
                 <a:latin typeface="Microsoft YaHei"/>
               </a:rPr>
-              <a:t>这样更容易先把“实时撤销 + 低开销 + 追责”三件事一起跑通</a:t>
+              <a:t>工程优先级：先稳妥落地，再考虑更激进的算法优化</a:t>
             </a:r>
           </a:p>
         </p:txBody>
@@ -4056,7 +4058,7 @@
         <p:spPr>
           <a:xfrm>
             <a:off x="548640" y="749808"/>
-            <a:ext cx="10972800" cy="731520"/>
+            <a:ext cx="10972800" cy="914400"/>
           </a:xfrm>
           <a:prstGeom prst="rect">
             <a:avLst/>
@@ -4076,7 +4078,7 @@
                 </a:solidFill>
                 <a:latin typeface="Microsoft YaHei"/>
               </a:rPr>
-              <a:t>10. 风险、边界与最终结论</a:t>
+              <a:t>10. 面向弱硬件的实现建议：三层协同，而不是 OBU 单扛</a:t>
             </a:r>
           </a:p>
         </p:txBody>
@@ -4118,7 +4120,7 @@
                 </a:solidFill>
                 <a:latin typeface="Microsoft YaHei"/>
               </a:rPr>
-              <a:t>风险 1：如果 RSU/MEC 覆盖不足，实时撤销效果会退化，需要短期证书自然过期兜底。</a:t>
+              <a:t>车端 OBU：缓存活跃伪名与最近撤销摘要，只做“过期检查 → 摘要命中检查 → 必要时补查”。</a:t>
             </a:r>
           </a:p>
           <a:p>
@@ -4137,7 +4139,7 @@
                 </a:solidFill>
                 <a:latin typeface="Microsoft YaHei"/>
               </a:rPr>
-              <a:t>风险 2：如果把 AI 检测直接绑定封禁动作，会出现“误报即封车”的治理风险。</a:t>
+              <a:t>路侧 RSU / MEC：按区域/时间/批次广播撤销增量，提供全量明细与证明材料，吸收重通信与重计算。</a:t>
             </a:r>
           </a:p>
           <a:p>
@@ -4156,7 +4158,7 @@
                 </a:solidFill>
                 <a:latin typeface="Microsoft YaHei"/>
               </a:rPr>
-              <a:t>风险 3：如果日志设计不当，追责链会反过来变成长期轨迹监控系统。</a:t>
+              <a:t>后台 PKI / 监管：输出权威撤销事件、版本链和审计记录，负责误报处置与条件解匿。</a:t>
             </a:r>
           </a:p>
           <a:p>
@@ -4175,7 +4177,7 @@
                 </a:solidFill>
                 <a:latin typeface="Microsoft YaHei"/>
               </a:rPr>
-              <a:t>最终结论：可以做，而且方向正确；但建议走“VPKI/SCMS 主线 + 边缘化撤销 + 条件解匿 + 轻量透明日志”的工程路线。</a:t>
+              <a:t>结果：把低时延判断留在本地，把全局一致性和重负载交给边缘与后台。</a:t>
             </a:r>
           </a:p>
         </p:txBody>
@@ -4210,7 +4212,7 @@
                 </a:solidFill>
                 <a:latin typeface="Microsoft YaHei"/>
               </a:rPr>
-              <a:t>推荐优先级：先证书与撤销，再追责闭环，最后再引入 AI/区块链增强层</a:t>
+              <a:t>适用于 DSRC / ITS-G5 / C-V2X 场景；5G-V2V 仍需要上层 ITS 安全机制</a:t>
             </a:r>
           </a:p>
         </p:txBody>
@@ -4414,7 +4416,7 @@
         <p:spPr>
           <a:xfrm>
             <a:off x="548640" y="749808"/>
-            <a:ext cx="10972800" cy="731520"/>
+            <a:ext cx="10972800" cy="914400"/>
           </a:xfrm>
           <a:prstGeom prst="rect">
             <a:avLst/>
@@ -4434,7 +4436,7 @@
                 </a:solidFill>
                 <a:latin typeface="Microsoft YaHei"/>
               </a:rPr>
-              <a:t>参考资料（真实可核验）</a:t>
+              <a:t>11. 分阶段落地路线图（建议先从封闭/半封闭场景起步）</a:t>
             </a:r>
           </a:p>
         </p:txBody>
@@ -4476,7 +4478,7 @@
                 </a:solidFill>
                 <a:latin typeface="Microsoft YaHei"/>
               </a:rPr>
-              <a:t>1) BSI TR-03164 Part 1: Guidance for C-ITS, Part 1: Operation of a Public Key Infrastructure for C-ITS, v1.0.0, 2021.</a:t>
+              <a:t>Phase 0（PoC）：基于 IEEE 1609.2 或 ETSI 102 941/103 097 跑通证书签发、增量撤销、补查、解匿闭环。</a:t>
             </a:r>
           </a:p>
           <a:p>
@@ -4495,7 +4497,7 @@
                 </a:solidFill>
                 <a:latin typeface="Microsoft YaHei"/>
               </a:rPr>
-              <a:t>2) BSI TR-03164 Part 2: Guidance for C-ITS, Part 2: Special Requirements for C-ITS Stations, v1.0.0, 2021.</a:t>
+              <a:t>Phase 1（边缘化）：CRL 切成区域 + 时间 + 批次三维差分，OBU 只保留当前窗口摘要。</a:t>
             </a:r>
           </a:p>
           <a:p>
@@ -4514,7 +4516,7 @@
                 </a:solidFill>
                 <a:latin typeface="Microsoft YaHei"/>
               </a:rPr>
-              <a:t>3) Vanetza Security README: ETSI C-ITS security module status and missing revocation/enrolment capabilities.</a:t>
+              <a:t>Phase 2（追责闭环）：关键事件进入本地签名审计日志，透明日志只记录摘要；调查时再生成证据包。</a:t>
             </a:r>
           </a:p>
           <a:p>
@@ -4533,7 +4535,7 @@
                 </a:solidFill>
                 <a:latin typeface="Microsoft YaHei"/>
               </a:rPr>
-              <a:t>4) Tim Weil, VPKI Hits the Highway – Secure Communication for the US DOT Connected Vehicle Pilot Program, 2017.</a:t>
+              <a:t>Phase 3（智能化）：AI/规则引擎只负责发现高风险行为，不直接下撤销决定。</a:t>
             </a:r>
           </a:p>
           <a:p>
@@ -4552,9 +4554,291 @@
                 </a:solidFill>
                 <a:latin typeface="Microsoft YaHei"/>
               </a:rPr>
-              <a:t>5) Andrea Tesei et al., A Transparent Distributed Ledger-based Certificate Revocation Scheme for VANETs, 2020.</a:t>
-            </a:r>
-          </a:p>
+              <a:t>首发场景建议：营运车队、物流园区、矿区、港口、两客一危等 RSU/MEC 可控场景。</a:t>
+            </a:r>
+          </a:p>
+        </p:txBody>
+      </p:sp>
+      <p:sp>
+        <p:nvSpPr>
+          <p:cNvPr id="7" name="TextBox 6"/>
+          <p:cNvSpPr txBox="1"/>
+          <p:nvPr/>
+        </p:nvSpPr>
+        <p:spPr>
+          <a:xfrm>
+            <a:off x="502920" y="6565392"/>
+            <a:ext cx="10789920" cy="201168"/>
+          </a:xfrm>
+          <a:prstGeom prst="rect">
+            <a:avLst/>
+          </a:prstGeom>
+          <a:noFill/>
+        </p:spPr>
+        <p:txBody>
+          <a:bodyPr wrap="none">
+            <a:spAutoFit/>
+          </a:bodyPr>
+          <a:lstStyle/>
+          <a:p>
+            <a:pPr algn="l"/>
+            <a:r>
+              <a:rPr sz="900">
+                <a:solidFill>
+                  <a:srgbClr val="5C6770"/>
+                </a:solidFill>
+                <a:latin typeface="Microsoft YaHei"/>
+              </a:rPr>
+              <a:t>这样更容易先把“实时撤销 + 低开销 + 追责”三件事一起跑通</a:t>
+            </a:r>
+          </a:p>
+        </p:txBody>
+      </p:sp>
+      <p:sp>
+        <p:nvSpPr>
+          <p:cNvPr id="8" name="TextBox 7"/>
+          <p:cNvSpPr txBox="1"/>
+          <p:nvPr/>
+        </p:nvSpPr>
+        <p:spPr>
+          <a:xfrm>
+            <a:off x="11292840" y="6547104"/>
+            <a:ext cx="365760" cy="228600"/>
+          </a:xfrm>
+          <a:prstGeom prst="rect">
+            <a:avLst/>
+          </a:prstGeom>
+          <a:noFill/>
+        </p:spPr>
+        <p:txBody>
+          <a:bodyPr wrap="none">
+            <a:spAutoFit/>
+          </a:bodyPr>
+          <a:lstStyle/>
+          <a:p>
+            <a:pPr algn="r"/>
+            <a:r>
+              <a:rPr sz="1000" b="1">
+                <a:solidFill>
+                  <a:srgbClr val="225DA8"/>
+                </a:solidFill>
+                <a:latin typeface="Microsoft YaHei"/>
+              </a:rPr>
+              <a:t>12</a:t>
+            </a:r>
+          </a:p>
+        </p:txBody>
+      </p:sp>
+    </p:spTree>
+  </p:cSld>
+  <p:clrMapOvr>
+    <a:masterClrMapping/>
+  </p:clrMapOvr>
+</p:sld>
+</file>
+
+<file path=ppt/slides/slide13.xml><?xml version="1.0" encoding="utf-8"?>
+<p:sld xmlns:a="http://schemas.openxmlformats.org/drawingml/2006/main" xmlns:p="http://schemas.openxmlformats.org/presentationml/2006/main" xmlns:r="http://schemas.openxmlformats.org/officeDocument/2006/relationships">
+  <p:cSld>
+    <p:bg>
+      <p:bgPr>
+        <a:solidFill>
+          <a:srgbClr val="FFFFFF"/>
+        </a:solidFill>
+        <a:effectLst/>
+      </p:bgPr>
+    </p:bg>
+    <p:spTree>
+      <p:nvGrpSpPr>
+        <p:cNvPr id="1" name=""/>
+        <p:cNvGrpSpPr/>
+        <p:nvPr/>
+      </p:nvGrpSpPr>
+      <p:grpSpPr/>
+      <p:sp>
+        <p:nvSpPr>
+          <p:cNvPr id="2" name="Rectangle 1"/>
+          <p:cNvSpPr/>
+          <p:nvPr/>
+        </p:nvSpPr>
+        <p:spPr>
+          <a:xfrm>
+            <a:off x="0" y="0"/>
+            <a:ext cx="12191695" cy="502920"/>
+          </a:xfrm>
+          <a:prstGeom prst="rect">
+            <a:avLst/>
+          </a:prstGeom>
+          <a:solidFill>
+            <a:srgbClr val="112D4E"/>
+          </a:solidFill>
+          <a:ln>
+            <a:noFill/>
+          </a:ln>
+        </p:spPr>
+        <p:style>
+          <a:lnRef idx="1">
+            <a:schemeClr val="accent1"/>
+          </a:lnRef>
+          <a:fillRef idx="3">
+            <a:schemeClr val="accent1"/>
+          </a:fillRef>
+          <a:effectRef idx="2">
+            <a:schemeClr val="accent1"/>
+          </a:effectRef>
+          <a:fontRef idx="minor">
+            <a:schemeClr val="lt1"/>
+          </a:fontRef>
+        </p:style>
+        <p:txBody>
+          <a:bodyPr rtlCol="0" anchor="ctr"/>
+          <a:lstStyle/>
+          <a:p>
+            <a:pPr algn="ctr"/>
+          </a:p>
+        </p:txBody>
+      </p:sp>
+      <p:sp>
+        <p:nvSpPr>
+          <p:cNvPr id="3" name="Rectangle 2"/>
+          <p:cNvSpPr/>
+          <p:nvPr/>
+        </p:nvSpPr>
+        <p:spPr>
+          <a:xfrm>
+            <a:off x="0" y="502920"/>
+            <a:ext cx="12191695" cy="73152"/>
+          </a:xfrm>
+          <a:prstGeom prst="rect">
+            <a:avLst/>
+          </a:prstGeom>
+          <a:solidFill>
+            <a:srgbClr val="225DA8"/>
+          </a:solidFill>
+          <a:ln>
+            <a:noFill/>
+          </a:ln>
+        </p:spPr>
+        <p:style>
+          <a:lnRef idx="1">
+            <a:schemeClr val="accent1"/>
+          </a:lnRef>
+          <a:fillRef idx="3">
+            <a:schemeClr val="accent1"/>
+          </a:fillRef>
+          <a:effectRef idx="2">
+            <a:schemeClr val="accent1"/>
+          </a:effectRef>
+          <a:fontRef idx="minor">
+            <a:schemeClr val="lt1"/>
+          </a:fontRef>
+        </p:style>
+        <p:txBody>
+          <a:bodyPr rtlCol="0" anchor="ctr"/>
+          <a:lstStyle/>
+          <a:p>
+            <a:pPr algn="ctr"/>
+          </a:p>
+        </p:txBody>
+      </p:sp>
+      <p:sp>
+        <p:nvSpPr>
+          <p:cNvPr id="4" name="Rectangle 3"/>
+          <p:cNvSpPr/>
+          <p:nvPr/>
+        </p:nvSpPr>
+        <p:spPr>
+          <a:xfrm>
+            <a:off x="0" y="6537960"/>
+            <a:ext cx="12191695" cy="320040"/>
+          </a:xfrm>
+          <a:prstGeom prst="rect">
+            <a:avLst/>
+          </a:prstGeom>
+          <a:solidFill>
+            <a:srgbClr val="F5F8FC"/>
+          </a:solidFill>
+          <a:ln>
+            <a:noFill/>
+          </a:ln>
+        </p:spPr>
+        <p:style>
+          <a:lnRef idx="1">
+            <a:schemeClr val="accent1"/>
+          </a:lnRef>
+          <a:fillRef idx="3">
+            <a:schemeClr val="accent1"/>
+          </a:fillRef>
+          <a:effectRef idx="2">
+            <a:schemeClr val="accent1"/>
+          </a:effectRef>
+          <a:fontRef idx="minor">
+            <a:schemeClr val="lt1"/>
+          </a:fontRef>
+        </p:style>
+        <p:txBody>
+          <a:bodyPr rtlCol="0" anchor="ctr"/>
+          <a:lstStyle/>
+          <a:p>
+            <a:pPr algn="ctr"/>
+          </a:p>
+        </p:txBody>
+      </p:sp>
+      <p:sp>
+        <p:nvSpPr>
+          <p:cNvPr id="5" name="TextBox 4"/>
+          <p:cNvSpPr txBox="1"/>
+          <p:nvPr/>
+        </p:nvSpPr>
+        <p:spPr>
+          <a:xfrm>
+            <a:off x="548640" y="749808"/>
+            <a:ext cx="10972800" cy="914400"/>
+          </a:xfrm>
+          <a:prstGeom prst="rect">
+            <a:avLst/>
+          </a:prstGeom>
+          <a:noFill/>
+        </p:spPr>
+        <p:txBody>
+          <a:bodyPr wrap="none">
+            <a:spAutoFit/>
+          </a:bodyPr>
+          <a:lstStyle/>
+          <a:p>
+            <a:r>
+              <a:rPr sz="2800" b="1">
+                <a:solidFill>
+                  <a:srgbClr val="112D4E"/>
+                </a:solidFill>
+                <a:latin typeface="Microsoft YaHei"/>
+              </a:rPr>
+              <a:t>12. 风险、边界与最终结论</a:t>
+            </a:r>
+          </a:p>
+        </p:txBody>
+      </p:sp>
+      <p:sp>
+        <p:nvSpPr>
+          <p:cNvPr id="6" name="TextBox 5"/>
+          <p:cNvSpPr txBox="1"/>
+          <p:nvPr/>
+        </p:nvSpPr>
+        <p:spPr>
+          <a:xfrm>
+            <a:off x="713232" y="1417320"/>
+            <a:ext cx="10744200" cy="4892040"/>
+          </a:xfrm>
+          <a:prstGeom prst="rect">
+            <a:avLst/>
+          </a:prstGeom>
+          <a:noFill/>
+        </p:spPr>
+        <p:txBody>
+          <a:bodyPr wrap="square">
+            <a:normAutofit/>
+          </a:bodyPr>
+          <a:lstStyle/>
           <a:p>
             <a:pPr>
               <a:lnSpc>
@@ -4571,7 +4855,7 @@
                 </a:solidFill>
                 <a:latin typeface="Microsoft YaHei"/>
               </a:rPr>
-              <a:t>6) Mujahid Muhammad, Ghazanfar Ali Safdar, 5G-based V2V broadcast communications: A security perspective, Array, 2021.</a:t>
+              <a:t>风险 1：如果 RSU/MEC 覆盖不足，实时撤销效果会退化，需要短期证书自然过期兜底。</a:t>
             </a:r>
           </a:p>
           <a:p>
@@ -4590,7 +4874,7 @@
                 </a:solidFill>
                 <a:latin typeface="Microsoft YaHei"/>
               </a:rPr>
-              <a:t>7) Pranav K. Singh et al., Blockchain Meets AI for Resilient and Intelligent Internet of Vehicles, 2021.</a:t>
+              <a:t>风险 2：如果把 AI 检测直接绑定封禁动作，会出现“误报即封车”的治理风险。</a:t>
             </a:r>
           </a:p>
           <a:p>
@@ -4609,7 +4893,26 @@
                 </a:solidFill>
                 <a:latin typeface="Microsoft YaHei"/>
               </a:rPr>
-              <a:t>8) ISO-TC204 ITS cybersecurity overview page: regulations and standards context for OBU/RSU lifecycle security.</a:t>
+              <a:t>风险 3：如果日志设计不当，追责链会反过来变成长期轨迹监控系统。</a:t>
+            </a:r>
+          </a:p>
+          <a:p>
+            <a:pPr>
+              <a:lnSpc>
+                <a:spcPct val="112000"/>
+              </a:lnSpc>
+              <a:spcAft>
+                <a:spcPts val="1200"/>
+              </a:spcAft>
+            </a:pPr>
+            <a:r>
+              <a:rPr sz="2000">
+                <a:solidFill>
+                  <a:srgbClr val="20272D"/>
+                </a:solidFill>
+                <a:latin typeface="Microsoft YaHei"/>
+              </a:rPr>
+              <a:t>最终结论：可以做，而且方向正确；推荐算法栈应优先选择 ECC 主线，而不是沿用 RSA 主线。</a:t>
             </a:r>
           </a:p>
         </p:txBody>
@@ -4644,7 +4947,7 @@
                 </a:solidFill>
                 <a:latin typeface="Microsoft YaHei"/>
               </a:rPr>
-              <a:t>源文件：docs/vanet-eati-research-deck.md；演示稿：docs/vanet-eati-research.pptx</a:t>
+              <a:t>推荐优先级：先证书与撤销，再追责闭环，最后再引入 AI/区块链增强层</a:t>
             </a:r>
           </a:p>
         </p:txBody>
@@ -4679,7 +4982,441 @@
                 </a:solidFill>
                 <a:latin typeface="Microsoft YaHei"/>
               </a:rPr>
-              <a:t>12</a:t>
+              <a:t>13</a:t>
+            </a:r>
+          </a:p>
+        </p:txBody>
+      </p:sp>
+    </p:spTree>
+  </p:cSld>
+  <p:clrMapOvr>
+    <a:masterClrMapping/>
+  </p:clrMapOvr>
+</p:sld>
+</file>
+
+<file path=ppt/slides/slide14.xml><?xml version="1.0" encoding="utf-8"?>
+<p:sld xmlns:a="http://schemas.openxmlformats.org/drawingml/2006/main" xmlns:p="http://schemas.openxmlformats.org/presentationml/2006/main" xmlns:r="http://schemas.openxmlformats.org/officeDocument/2006/relationships">
+  <p:cSld>
+    <p:bg>
+      <p:bgPr>
+        <a:solidFill>
+          <a:srgbClr val="FFFFFF"/>
+        </a:solidFill>
+        <a:effectLst/>
+      </p:bgPr>
+    </p:bg>
+    <p:spTree>
+      <p:nvGrpSpPr>
+        <p:cNvPr id="1" name=""/>
+        <p:cNvGrpSpPr/>
+        <p:nvPr/>
+      </p:nvGrpSpPr>
+      <p:grpSpPr/>
+      <p:sp>
+        <p:nvSpPr>
+          <p:cNvPr id="2" name="Rectangle 1"/>
+          <p:cNvSpPr/>
+          <p:nvPr/>
+        </p:nvSpPr>
+        <p:spPr>
+          <a:xfrm>
+            <a:off x="0" y="0"/>
+            <a:ext cx="12191695" cy="502920"/>
+          </a:xfrm>
+          <a:prstGeom prst="rect">
+            <a:avLst/>
+          </a:prstGeom>
+          <a:solidFill>
+            <a:srgbClr val="112D4E"/>
+          </a:solidFill>
+          <a:ln>
+            <a:noFill/>
+          </a:ln>
+        </p:spPr>
+        <p:style>
+          <a:lnRef idx="1">
+            <a:schemeClr val="accent1"/>
+          </a:lnRef>
+          <a:fillRef idx="3">
+            <a:schemeClr val="accent1"/>
+          </a:fillRef>
+          <a:effectRef idx="2">
+            <a:schemeClr val="accent1"/>
+          </a:effectRef>
+          <a:fontRef idx="minor">
+            <a:schemeClr val="lt1"/>
+          </a:fontRef>
+        </p:style>
+        <p:txBody>
+          <a:bodyPr rtlCol="0" anchor="ctr"/>
+          <a:lstStyle/>
+          <a:p>
+            <a:pPr algn="ctr"/>
+          </a:p>
+        </p:txBody>
+      </p:sp>
+      <p:sp>
+        <p:nvSpPr>
+          <p:cNvPr id="3" name="Rectangle 2"/>
+          <p:cNvSpPr/>
+          <p:nvPr/>
+        </p:nvSpPr>
+        <p:spPr>
+          <a:xfrm>
+            <a:off x="0" y="502920"/>
+            <a:ext cx="12191695" cy="73152"/>
+          </a:xfrm>
+          <a:prstGeom prst="rect">
+            <a:avLst/>
+          </a:prstGeom>
+          <a:solidFill>
+            <a:srgbClr val="1D7A57"/>
+          </a:solidFill>
+          <a:ln>
+            <a:noFill/>
+          </a:ln>
+        </p:spPr>
+        <p:style>
+          <a:lnRef idx="1">
+            <a:schemeClr val="accent1"/>
+          </a:lnRef>
+          <a:fillRef idx="3">
+            <a:schemeClr val="accent1"/>
+          </a:fillRef>
+          <a:effectRef idx="2">
+            <a:schemeClr val="accent1"/>
+          </a:effectRef>
+          <a:fontRef idx="minor">
+            <a:schemeClr val="lt1"/>
+          </a:fontRef>
+        </p:style>
+        <p:txBody>
+          <a:bodyPr rtlCol="0" anchor="ctr"/>
+          <a:lstStyle/>
+          <a:p>
+            <a:pPr algn="ctr"/>
+          </a:p>
+        </p:txBody>
+      </p:sp>
+      <p:sp>
+        <p:nvSpPr>
+          <p:cNvPr id="4" name="Rectangle 3"/>
+          <p:cNvSpPr/>
+          <p:nvPr/>
+        </p:nvSpPr>
+        <p:spPr>
+          <a:xfrm>
+            <a:off x="0" y="6537960"/>
+            <a:ext cx="12191695" cy="320040"/>
+          </a:xfrm>
+          <a:prstGeom prst="rect">
+            <a:avLst/>
+          </a:prstGeom>
+          <a:solidFill>
+            <a:srgbClr val="F5F8FC"/>
+          </a:solidFill>
+          <a:ln>
+            <a:noFill/>
+          </a:ln>
+        </p:spPr>
+        <p:style>
+          <a:lnRef idx="1">
+            <a:schemeClr val="accent1"/>
+          </a:lnRef>
+          <a:fillRef idx="3">
+            <a:schemeClr val="accent1"/>
+          </a:fillRef>
+          <a:effectRef idx="2">
+            <a:schemeClr val="accent1"/>
+          </a:effectRef>
+          <a:fontRef idx="minor">
+            <a:schemeClr val="lt1"/>
+          </a:fontRef>
+        </p:style>
+        <p:txBody>
+          <a:bodyPr rtlCol="0" anchor="ctr"/>
+          <a:lstStyle/>
+          <a:p>
+            <a:pPr algn="ctr"/>
+          </a:p>
+        </p:txBody>
+      </p:sp>
+      <p:sp>
+        <p:nvSpPr>
+          <p:cNvPr id="5" name="TextBox 4"/>
+          <p:cNvSpPr txBox="1"/>
+          <p:nvPr/>
+        </p:nvSpPr>
+        <p:spPr>
+          <a:xfrm>
+            <a:off x="548640" y="749808"/>
+            <a:ext cx="10972800" cy="914400"/>
+          </a:xfrm>
+          <a:prstGeom prst="rect">
+            <a:avLst/>
+          </a:prstGeom>
+          <a:noFill/>
+        </p:spPr>
+        <p:txBody>
+          <a:bodyPr wrap="none">
+            <a:spAutoFit/>
+          </a:bodyPr>
+          <a:lstStyle/>
+          <a:p>
+            <a:r>
+              <a:rPr sz="2800" b="1">
+                <a:solidFill>
+                  <a:srgbClr val="112D4E"/>
+                </a:solidFill>
+                <a:latin typeface="Microsoft YaHei"/>
+              </a:rPr>
+              <a:t>参考资料（真实可核验）</a:t>
+            </a:r>
+          </a:p>
+        </p:txBody>
+      </p:sp>
+      <p:sp>
+        <p:nvSpPr>
+          <p:cNvPr id="6" name="TextBox 5"/>
+          <p:cNvSpPr txBox="1"/>
+          <p:nvPr/>
+        </p:nvSpPr>
+        <p:spPr>
+          <a:xfrm>
+            <a:off x="713232" y="1417320"/>
+            <a:ext cx="10744200" cy="4892040"/>
+          </a:xfrm>
+          <a:prstGeom prst="rect">
+            <a:avLst/>
+          </a:prstGeom>
+          <a:noFill/>
+        </p:spPr>
+        <p:txBody>
+          <a:bodyPr wrap="square">
+            <a:normAutofit/>
+          </a:bodyPr>
+          <a:lstStyle/>
+          <a:p>
+            <a:pPr>
+              <a:lnSpc>
+                <a:spcPct val="112000"/>
+              </a:lnSpc>
+              <a:spcAft>
+                <a:spcPts val="1200"/>
+              </a:spcAft>
+            </a:pPr>
+            <a:r>
+              <a:rPr sz="2000">
+                <a:solidFill>
+                  <a:srgbClr val="20272D"/>
+                </a:solidFill>
+                <a:latin typeface="Microsoft YaHei"/>
+              </a:rPr>
+              <a:t>1) BSI TR-03164 Part 1: Guidance for C-ITS, Part 1: Operation of a Public Key Infrastructure for C-ITS, v1.0.0, 2021.</a:t>
+            </a:r>
+          </a:p>
+          <a:p>
+            <a:pPr>
+              <a:lnSpc>
+                <a:spcPct val="112000"/>
+              </a:lnSpc>
+              <a:spcAft>
+                <a:spcPts val="1200"/>
+              </a:spcAft>
+            </a:pPr>
+            <a:r>
+              <a:rPr sz="2000">
+                <a:solidFill>
+                  <a:srgbClr val="20272D"/>
+                </a:solidFill>
+                <a:latin typeface="Microsoft YaHei"/>
+              </a:rPr>
+              <a:t>2) BSI TR-03164 Part 2: Guidance for C-ITS, Part 2: Special Requirements for C-ITS Stations, v1.0.0, 2021.</a:t>
+            </a:r>
+          </a:p>
+          <a:p>
+            <a:pPr>
+              <a:lnSpc>
+                <a:spcPct val="112000"/>
+              </a:lnSpc>
+              <a:spcAft>
+                <a:spcPts val="1200"/>
+              </a:spcAft>
+            </a:pPr>
+            <a:r>
+              <a:rPr sz="2000">
+                <a:solidFill>
+                  <a:srgbClr val="20272D"/>
+                </a:solidFill>
+                <a:latin typeface="Microsoft YaHei"/>
+              </a:rPr>
+              <a:t>3) Vanetza Security README: ETSI C-ITS security module status and missing revocation/enrolment capabilities.</a:t>
+            </a:r>
+          </a:p>
+          <a:p>
+            <a:pPr>
+              <a:lnSpc>
+                <a:spcPct val="112000"/>
+              </a:lnSpc>
+              <a:spcAft>
+                <a:spcPts val="1200"/>
+              </a:spcAft>
+            </a:pPr>
+            <a:r>
+              <a:rPr sz="2000">
+                <a:solidFill>
+                  <a:srgbClr val="20272D"/>
+                </a:solidFill>
+                <a:latin typeface="Microsoft YaHei"/>
+              </a:rPr>
+              <a:t>4) Tim Weil, VPKI Hits the Highway – Secure Communication for the US DOT Connected Vehicle Pilot Program, 2017.</a:t>
+            </a:r>
+          </a:p>
+          <a:p>
+            <a:pPr>
+              <a:lnSpc>
+                <a:spcPct val="112000"/>
+              </a:lnSpc>
+              <a:spcAft>
+                <a:spcPts val="1200"/>
+              </a:spcAft>
+            </a:pPr>
+            <a:r>
+              <a:rPr sz="2000">
+                <a:solidFill>
+                  <a:srgbClr val="20272D"/>
+                </a:solidFill>
+                <a:latin typeface="Microsoft YaHei"/>
+              </a:rPr>
+              <a:t>5) Andrea Tesei et al., A Transparent Distributed Ledger-based Certificate Revocation Scheme for VANETs, 2020.</a:t>
+            </a:r>
+          </a:p>
+          <a:p>
+            <a:pPr>
+              <a:lnSpc>
+                <a:spcPct val="112000"/>
+              </a:lnSpc>
+              <a:spcAft>
+                <a:spcPts val="1200"/>
+              </a:spcAft>
+            </a:pPr>
+            <a:r>
+              <a:rPr sz="2000">
+                <a:solidFill>
+                  <a:srgbClr val="20272D"/>
+                </a:solidFill>
+                <a:latin typeface="Microsoft YaHei"/>
+              </a:rPr>
+              <a:t>6) Mujahid Muhammad, Ghazanfar Ali Safdar, 5G-based V2V broadcast communications: A security perspective, Array, 2021.</a:t>
+            </a:r>
+          </a:p>
+          <a:p>
+            <a:pPr>
+              <a:lnSpc>
+                <a:spcPct val="112000"/>
+              </a:lnSpc>
+              <a:spcAft>
+                <a:spcPts val="1200"/>
+              </a:spcAft>
+            </a:pPr>
+            <a:r>
+              <a:rPr sz="2000">
+                <a:solidFill>
+                  <a:srgbClr val="20272D"/>
+                </a:solidFill>
+                <a:latin typeface="Microsoft YaHei"/>
+              </a:rPr>
+              <a:t>7) Pranav K. Singh et al., Blockchain Meets AI for Resilient and Intelligent Internet of Vehicles, 2021.</a:t>
+            </a:r>
+          </a:p>
+          <a:p>
+            <a:pPr>
+              <a:lnSpc>
+                <a:spcPct val="112000"/>
+              </a:lnSpc>
+              <a:spcAft>
+                <a:spcPts val="1200"/>
+              </a:spcAft>
+            </a:pPr>
+            <a:r>
+              <a:rPr sz="2000">
+                <a:solidFill>
+                  <a:srgbClr val="20272D"/>
+                </a:solidFill>
+                <a:latin typeface="Microsoft YaHei"/>
+              </a:rPr>
+              <a:t>8) ISO-TC204 ITS cybersecurity overview page: regulations and standards context for OBU/RSU lifecycle security.</a:t>
+            </a:r>
+          </a:p>
+        </p:txBody>
+      </p:sp>
+      <p:sp>
+        <p:nvSpPr>
+          <p:cNvPr id="7" name="TextBox 6"/>
+          <p:cNvSpPr txBox="1"/>
+          <p:nvPr/>
+        </p:nvSpPr>
+        <p:spPr>
+          <a:xfrm>
+            <a:off x="502920" y="6565392"/>
+            <a:ext cx="10789920" cy="201168"/>
+          </a:xfrm>
+          <a:prstGeom prst="rect">
+            <a:avLst/>
+          </a:prstGeom>
+          <a:noFill/>
+        </p:spPr>
+        <p:txBody>
+          <a:bodyPr wrap="none">
+            <a:spAutoFit/>
+          </a:bodyPr>
+          <a:lstStyle/>
+          <a:p>
+            <a:pPr algn="l"/>
+            <a:r>
+              <a:rPr sz="900">
+                <a:solidFill>
+                  <a:srgbClr val="5C6770"/>
+                </a:solidFill>
+                <a:latin typeface="Microsoft YaHei"/>
+              </a:rPr>
+              <a:t>源文件：docs/vanet-eati-research-deck.md；演示稿：docs/vanet-eati-research.pptx</a:t>
+            </a:r>
+          </a:p>
+        </p:txBody>
+      </p:sp>
+      <p:sp>
+        <p:nvSpPr>
+          <p:cNvPr id="8" name="TextBox 7"/>
+          <p:cNvSpPr txBox="1"/>
+          <p:nvPr/>
+        </p:nvSpPr>
+        <p:spPr>
+          <a:xfrm>
+            <a:off x="11292840" y="6547104"/>
+            <a:ext cx="365760" cy="228600"/>
+          </a:xfrm>
+          <a:prstGeom prst="rect">
+            <a:avLst/>
+          </a:prstGeom>
+          <a:noFill/>
+        </p:spPr>
+        <p:txBody>
+          <a:bodyPr wrap="none">
+            <a:spAutoFit/>
+          </a:bodyPr>
+          <a:lstStyle/>
+          <a:p>
+            <a:pPr algn="r"/>
+            <a:r>
+              <a:rPr sz="1000" b="1">
+                <a:solidFill>
+                  <a:srgbClr val="225DA8"/>
+                </a:solidFill>
+                <a:latin typeface="Microsoft YaHei"/>
+              </a:rPr>
+              <a:t>14</a:t>
             </a:r>
           </a:p>
         </p:txBody>
@@ -4848,7 +5585,7 @@
         <p:spPr>
           <a:xfrm>
             <a:off x="548640" y="749808"/>
-            <a:ext cx="10972800" cy="731520"/>
+            <a:ext cx="10972800" cy="914400"/>
           </a:xfrm>
           <a:prstGeom prst="rect">
             <a:avLst/>
@@ -5206,7 +5943,7 @@
         <p:spPr>
           <a:xfrm>
             <a:off x="548640" y="749808"/>
-            <a:ext cx="10972800" cy="731520"/>
+            <a:ext cx="10972800" cy="914400"/>
           </a:xfrm>
           <a:prstGeom prst="rect">
             <a:avLst/>
@@ -5564,7 +6301,7 @@
         <p:spPr>
           <a:xfrm>
             <a:off x="548640" y="749808"/>
-            <a:ext cx="10972800" cy="731520"/>
+            <a:ext cx="10972800" cy="914400"/>
           </a:xfrm>
           <a:prstGeom prst="rect">
             <a:avLst/>
@@ -5922,7 +6659,7 @@
         <p:spPr>
           <a:xfrm>
             <a:off x="548640" y="749808"/>
-            <a:ext cx="10972800" cy="731520"/>
+            <a:ext cx="10972800" cy="914400"/>
           </a:xfrm>
           <a:prstGeom prst="rect">
             <a:avLst/>
@@ -6280,7 +7017,7 @@
         <p:spPr>
           <a:xfrm>
             <a:off x="548640" y="749808"/>
-            <a:ext cx="10972800" cy="731520"/>
+            <a:ext cx="10972800" cy="914400"/>
           </a:xfrm>
           <a:prstGeom prst="rect">
             <a:avLst/>
@@ -6657,7 +7394,7 @@
         <p:spPr>
           <a:xfrm>
             <a:off x="548640" y="749808"/>
-            <a:ext cx="10972800" cy="731520"/>
+            <a:ext cx="10972800" cy="914400"/>
           </a:xfrm>
           <a:prstGeom prst="rect">
             <a:avLst/>
@@ -7015,7 +7752,7 @@
         <p:spPr>
           <a:xfrm>
             <a:off x="548640" y="749808"/>
-            <a:ext cx="10972800" cy="731520"/>
+            <a:ext cx="10972800" cy="914400"/>
           </a:xfrm>
           <a:prstGeom prst="rect">
             <a:avLst/>
@@ -7392,7 +8129,7 @@
         <p:spPr>
           <a:xfrm>
             <a:off x="548640" y="749808"/>
-            <a:ext cx="10972800" cy="731520"/>
+            <a:ext cx="10972800" cy="914400"/>
           </a:xfrm>
           <a:prstGeom prst="rect">
             <a:avLst/>
@@ -7412,7 +8149,7 @@
                 </a:solidFill>
                 <a:latin typeface="Microsoft YaHei"/>
               </a:rPr>
-              <a:t>8. 面向弱硬件的实现建议：三层协同，而不是 OBU 单扛</a:t>
+              <a:t>8. 推荐密码学算法：先给结论</a:t>
             </a:r>
           </a:p>
         </p:txBody>
@@ -7454,7 +8191,7 @@
                 </a:solidFill>
                 <a:latin typeface="Microsoft YaHei"/>
               </a:rPr>
-              <a:t>车端 OBU：缓存活跃伪名与最近撤销摘要，只做“过期检查 → 摘要命中检查 → 必要时补查”。</a:t>
+              <a:t>消息签名：首选 ECDSA P-256 + SHA-256，而不是把当前 SDK 的 RSA-2048 直接搬到 VANET 消息面。</a:t>
             </a:r>
           </a:p>
           <a:p>
@@ -7473,7 +8210,7 @@
                 </a:solidFill>
                 <a:latin typeface="Microsoft YaHei"/>
               </a:rPr>
-              <a:t>路侧 RSU / MEC：按区域/时间/批次广播撤销增量，提供全量明细与证明材料，吸收重通信与重计算。</a:t>
+              <a:t>密钥协商：需要保密信道时，用 ECDH P-256；OBU ↔ RSU/MEC 管理面再配 AES-128-GCM。</a:t>
             </a:r>
           </a:p>
           <a:p>
@@ -7492,7 +8229,7 @@
                 </a:solidFill>
                 <a:latin typeface="Microsoft YaHei"/>
               </a:rPr>
-              <a:t>后台 PKI / 监管：输出权威撤销事件、版本链和审计记录，负责误报处置与条件解匿。</a:t>
+              <a:t>摘要与日志：统一走 SHA-256；透明日志和撤销版本链优先采用 Merkle Tree。</a:t>
             </a:r>
           </a:p>
           <a:p>
@@ -7511,7 +8248,26 @@
                 </a:solidFill>
                 <a:latin typeface="Microsoft YaHei"/>
               </a:rPr>
-              <a:t>结果：把低时延判断留在本地，把全局一致性和重负载交给边缘与后台。</a:t>
+              <a:t>条件解匿：身份映射不要由单机构独占，优先 2-of-3 门限密钥或 Shamir Secret Sharing。</a:t>
+            </a:r>
+          </a:p>
+          <a:p>
+            <a:pPr>
+              <a:lnSpc>
+                <a:spcPct val="112000"/>
+              </a:lnSpc>
+              <a:spcAft>
+                <a:spcPts val="1200"/>
+              </a:spcAft>
+            </a:pPr>
+            <a:r>
+              <a:rPr sz="2000">
+                <a:solidFill>
+                  <a:srgbClr val="20272D"/>
+                </a:solidFill>
+                <a:latin typeface="Microsoft YaHei"/>
+              </a:rPr>
+              <a:t>一句话组合：ECDSA P-256 + ECDH P-256 + SHA-256 + AES-128-GCM + Merkle 透明日志 + 门限解匿。</a:t>
             </a:r>
           </a:p>
         </p:txBody>
@@ -7546,7 +8302,7 @@
                 </a:solidFill>
                 <a:latin typeface="Microsoft YaHei"/>
               </a:rPr>
-              <a:t>适用于 DSRC / ITS-G5 / C-V2X 场景；5G-V2V 仍需要上层 ITS 安全机制</a:t>
+              <a:t>推荐原则：标准兼容优先、车端轻量优先、监管分权优先</a:t>
             </a:r>
           </a:p>
         </p:txBody>

</xml_diff>